<commit_message>
Setup wizard, owner login, and online deployment
- /setup: 10-step wizard (owner password, shop, products table + CSV import, shipping, AI presets with live test,
  WhatsApp guided setup + test send + template auto-creation, owner alerts via WhatsApp/Telegram (/owner code),
  courier Bosta/own driver, business numbers, go-live checklist). Changes apply live, no restart.
- config: env > wizard(settings.json) > defaults; per-install data dir (instance/ locally, /data in Docker)
- auth: owner password (pbkdf2), 30-day session; localhost works without password; fresh online server is
  claimable only via one-time setup link in logs; webhooks stay public
- deploy: render.yaml (one-click, persistent disk), Docker volume, run.bat/run.sh online (Cloudflare tunnel)
- docs/deploy.md; 52 tests
</commit_message>
<xml_diff>
--- a/docs/Ta2keed-impact-slides.pptx
+++ b/docs/Ta2keed-impact-slides.pptx
@@ -7183,7 +7183,7 @@
                 </a:solidFill>
                 <a:latin typeface="Consolas"/>
               </a:rPr>
-              <a:t>pytest -q       # 35 tests</a:t>
+              <a:t>pytest -q       # 52 tests</a:t>
             </a:r>
           </a:p>
         </p:txBody>
@@ -16268,7 +16268,7 @@
                 </a:solidFill>
                 <a:latin typeface="Segoe UI"/>
               </a:rPr>
-              <a:t>Runs in &lt; 5 min with no API keys (./run.sh → ▶ Play demo)  ·  35 automated tests</a:t>
+              <a:t>Runs in &lt; 5 min with no API keys (./run.sh → ▶ Play demo)  ·  52 automated tests</a:t>
             </a:r>
           </a:p>
         </p:txBody>

</xml_diff>

<commit_message>
Owner payment confirmation (2nd fraud layer), security hardening, Apple-style redesign
- Receipts that pass automatic checks now wait for the owner: screenshot + details sent to
  Telegram (inline buttons) / WhatsApp (reply buttons or quick-reply template), dashboard card,
  text replies 'تم 1234' / 'لا 1234', reminders at 30 min / 3 h, nothing ships before approval.
  Reused screenshots/references blocked even while pending. Policy toggle in the wizard.
- Secrets encrypted at rest (Fernet), CSP/HSTS/nosniff headers, CSRF same-origin check,
  login rate limit, secure cookies, 0600 files, backup + customer export/erase endpoints.
- New light/dark design system for dashboard, wizard and login; escaped rendering.
- docs/security.md; README, deploy, slides updated. 71 tests.
</commit_message>
<xml_diff>
--- a/docs/Ta2keed-impact-slides.pptx
+++ b/docs/Ta2keed-impact-slides.pptx
@@ -7183,7 +7183,7 @@
                 </a:solidFill>
                 <a:latin typeface="Consolas"/>
               </a:rPr>
-              <a:t>pytest -q       # 52 tests</a:t>
+              <a:t>pytest -q       # 71 tests</a:t>
             </a:r>
           </a:p>
         </p:txBody>
@@ -7407,7 +7407,7 @@
                 </a:solidFill>
                 <a:latin typeface="Segoe UI"/>
               </a:rPr>
-              <a:t>Risky first-time order → InstaPay deposit → fake screenshot caught → real one accepted</a:t>
+              <a:t>Risky first-time order → deposit → fake receipt caught → owner confirms real transfer → shipped</a:t>
             </a:r>
           </a:p>
         </p:txBody>
@@ -8077,7 +8077,7 @@
                 </a:solidFill>
                 <a:latin typeface="Segoe UI"/>
               </a:rPr>
-              <a:t>Checks recipient, amount, status, duplicate reference &amp; image hash; flags edited-looking screenshots; owner alert</a:t>
+              <a:t>Checks recipient, amount, status, duplicate reference &amp; image hash; then the OWNER confirms the money arrived in the bank app before shipping (AI-made or recycled screenshots can't pass)</a:t>
             </a:r>
           </a:p>
         </p:txBody>
@@ -13271,7 +13271,7 @@
                 </a:solidFill>
                 <a:latin typeface="Segoe UI"/>
               </a:rPr>
-              <a:t>Receipt fraud checks: recipient, amount, status, re-use</a:t>
+              <a:t>Auto receipt checks, then owner taps ✅ (money arrived)</a:t>
             </a:r>
           </a:p>
         </p:txBody>
@@ -15283,7 +15283,7 @@
                 </a:solidFill>
                 <a:latin typeface="Segoe UI"/>
               </a:rPr>
-              <a:t>A live agent: 5 real conversations, zero human touches</a:t>
+              <a:t>A live agent: 5 real conversations, one tap from the owner</a:t>
             </a:r>
           </a:p>
         </p:txBody>
@@ -15375,7 +15375,7 @@
         <p:spPr>
           <a:xfrm>
             <a:off x="548640" y="1554480"/>
-            <a:ext cx="6675120" cy="4227576"/>
+            <a:ext cx="6675120" cy="4635500"/>
           </a:xfrm>
           <a:prstGeom prst="rect">
             <a:avLst/>
@@ -16093,7 +16093,7 @@
                 </a:solidFill>
                 <a:latin typeface="Segoe UI"/>
               </a:rPr>
-              <a:t>4 → 4</a:t>
+              <a:t>4 → 5</a:t>
             </a:r>
           </a:p>
         </p:txBody>
@@ -16198,7 +16198,7 @@
                 </a:solidFill>
                 <a:latin typeface="Segoe UI"/>
               </a:rPr>
-              <a:t>Human minutes spent</a:t>
+              <a:t>Owner taps (deposit confirmed)</a:t>
             </a:r>
           </a:p>
         </p:txBody>
@@ -16233,7 +16233,7 @@
                 </a:solidFill>
                 <a:latin typeface="Segoe UI"/>
               </a:rPr>
-              <a:t>0</a:t>
+              <a:t>1</a:t>
             </a:r>
           </a:p>
         </p:txBody>
@@ -16268,7 +16268,7 @@
                 </a:solidFill>
                 <a:latin typeface="Segoe UI"/>
               </a:rPr>
-              <a:t>Runs in &lt; 5 min with no API keys (./run.sh → ▶ Play demo)  ·  52 automated tests</a:t>
+              <a:t>Runs in &lt; 5 min with no API keys (./run.sh → ▶ Play demo)  ·  71 automated tests</a:t>
             </a:r>
           </a:p>
         </p:txBody>
@@ -18255,7 +18255,7 @@
                 </a:solidFill>
                 <a:latin typeface="Segoe UI"/>
               </a:rPr>
-              <a:t>InstaPay &amp; Vodafone Cash deposits with screenshot fraud checks (wrong account, low amount, failed, reused)</a:t>
+              <a:t>InstaPay &amp; Vodafone Cash deposits: auto fraud checks (wrong account, low amount, reused) + owner taps ✅ on Telegram/WhatsApp before anything ships</a:t>
             </a:r>
           </a:p>
         </p:txBody>

</xml_diff>